<commit_message>
Added DevOps Learning Content - Linux
</commit_message>
<xml_diff>
--- a/linux/presentation/linux.pptx
+++ b/linux/presentation/linux.pptx
@@ -506,7 +506,7 @@
           <a:lstStyle/>
           <a:p>
             <a:r>
-              <a:t>Welcome the candidate and outline the primary objectives for this topic.</a:t>
+              <a:t>Overview of Linux kernel architecture, SRE responsibilities, and how resource limits scale systems.</a:t>
             </a:r>
           </a:p>
         </p:txBody>
@@ -576,7 +576,7 @@
           <a:lstStyle/>
           <a:p>
             <a:r>
-              <a:t>Explain the data path and recovery mechanism during failover events.</a:t>
+              <a:t>Explain how file descriptors scale and what happens to active sockets when backlog queues fill up.</a:t>
             </a:r>
           </a:p>
         </p:txBody>
@@ -646,7 +646,7 @@
           <a:lstStyle/>
           <a:p>
             <a:r>
-              <a:t>Emphasize key IAM principles and how telemetry shapes modern incident response.</a:t>
+              <a:t>Discuss how systemd uses namespaces programmatically to secure daemons at zero runtime cost.</a:t>
             </a:r>
           </a:p>
         </p:txBody>
@@ -716,7 +716,7 @@
           <a:lstStyle/>
           <a:p>
             <a:r>
-              <a:t>Walk through a hypothetical network outage scenario and recovery path.</a:t>
+              <a:t>Walk through a typical 3:00 AM log rotation failure and explain the direct steps to resolve it.</a:t>
             </a:r>
           </a:p>
         </p:txBody>
@@ -786,7 +786,7 @@
           <a:lstStyle/>
           <a:p>
             <a:r>
-              <a:t>Encourage the candidate to focus on practical hands-on labs and mini-projects.</a:t>
+              <a:t>Encourage focusing on system diagnostics, structural analysis, and performance tuning.</a:t>
             </a:r>
           </a:p>
         </p:txBody>
@@ -3925,7 +3925,7 @@
               </a:defRPr>
             </a:pPr>
             <a:r>
-              <a:t>Mastering Linux</a:t>
+              <a:t>Mastering Linux Systems</a:t>
             </a:r>
           </a:p>
           <a:p>
@@ -3941,7 +3941,7 @@
               </a:defRPr>
             </a:pPr>
             <a:r>
-              <a:t>Enterprise Architecture &amp; SRE Strategy</a:t>
+              <a:t>Enterprise Kernel Hardening &amp; SRE Architecture</a:t>
             </a:r>
           </a:p>
         </p:txBody>
@@ -4074,7 +4074,7 @@
               </a:defRPr>
             </a:pPr>
             <a:r>
-              <a:t>Enterprise System Architecture</a:t>
+              <a:t>Kernel Tuning &amp; Performance</a:t>
             </a:r>
           </a:p>
           <a:p>
@@ -4090,7 +4090,7 @@
               </a:defRPr>
             </a:pPr>
             <a:r>
-              <a:t>Production Topology &amp; Data Flow in Linux</a:t>
+              <a:t>Critical /etc/sysctl.conf Hardening for Web Traffic</a:t>
             </a:r>
           </a:p>
         </p:txBody>
@@ -4148,7 +4148,7 @@
               </a:defRPr>
             </a:pPr>
             <a:r>
-              <a:t>•   Redundant multi-AZ node configuration</a:t>
+              <a:t>•   Scale open file limits (fs.file-max = 2097152) for heavy workloads</a:t>
             </a:r>
           </a:p>
           <a:p>
@@ -4167,7 +4167,7 @@
               </a:defRPr>
             </a:pPr>
             <a:r>
-              <a:t>•   Zero-downtime rolling update mechanics</a:t>
+              <a:t>•   Tuning vm.swappiness=10 protects physical application memory</a:t>
             </a:r>
           </a:p>
         </p:txBody>
@@ -4313,7 +4313,7 @@
               </a:defRPr>
             </a:pPr>
             <a:r>
-              <a:t>•   Strict private subnet security groups isolation</a:t>
+              <a:t>•   Tuning net.core.somaxconn=65535 manages socket queues</a:t>
             </a:r>
           </a:p>
           <a:p>
@@ -4329,7 +4329,7 @@
               </a:defRPr>
             </a:pPr>
             <a:r>
-              <a:t>Key Takeaway: Ensure zero single point of failure at every level.</a:t>
+              <a:t>Key Takeaway: Kernel parameters shape the system capacity under massive load.</a:t>
             </a:r>
           </a:p>
         </p:txBody>
@@ -4426,7 +4426,7 @@
               </a:defRPr>
             </a:pPr>
             <a:r>
-              <a:t>Production Hardening &amp; DevSecOps</a:t>
+              <a:t>Hardened Service Isolation</a:t>
             </a:r>
           </a:p>
           <a:p>
@@ -4442,7 +4442,7 @@
               </a:defRPr>
             </a:pPr>
             <a:r>
-              <a:t>Security Best Practices &amp; Monitoring for Linux</a:t>
+              <a:t>SRE Sandboxing with systemd and Namespaces</a:t>
             </a:r>
           </a:p>
         </p:txBody>
@@ -4500,7 +4500,7 @@
               </a:defRPr>
             </a:pPr>
             <a:r>
-              <a:t>•   Enforced SSL/TLS mutual authentication (mTLS)</a:t>
+              <a:t>•   Use ProtectSystem=strict to set root directories read-only</a:t>
             </a:r>
           </a:p>
           <a:p>
@@ -4519,7 +4519,7 @@
               </a:defRPr>
             </a:pPr>
             <a:r>
-              <a:t>•   Real-time resource exhaustion alerts (Prometheus)</a:t>
+              <a:t>•   Implement PrivateTmp=yes to isolate temp folders per process</a:t>
             </a:r>
           </a:p>
         </p:txBody>
@@ -4665,7 +4665,7 @@
               </a:defRPr>
             </a:pPr>
             <a:r>
-              <a:t>•   Role-Based Access Control (RBAC) principle of least privilege</a:t>
+              <a:t>•   Enforce NoNewPrivileges=yes to block privilege escalation</a:t>
             </a:r>
           </a:p>
           <a:p>
@@ -4681,7 +4681,7 @@
               </a:defRPr>
             </a:pPr>
             <a:r>
-              <a:t>Key Takeaway: Security is not an afterthought; it must be baked into code.</a:t>
+              <a:t>Key Takeaway: Isolate microservices to protect host layers against security exploits.</a:t>
             </a:r>
           </a:p>
         </p:txBody>
@@ -4778,7 +4778,7 @@
               </a:defRPr>
             </a:pPr>
             <a:r>
-              <a:t>SRE &amp; Production Troubleshooting</a:t>
+              <a:t>SRE Incident Troubleshooting</a:t>
             </a:r>
           </a:p>
           <a:p>
@@ -4794,7 +4794,7 @@
               </a:defRPr>
             </a:pPr>
             <a:r>
-              <a:t>Incident Scenarios &amp; Root Cause Analysis (RCA)</a:t>
+              <a:t>The Deleted Open File Disk Exhaustion Outage</a:t>
             </a:r>
           </a:p>
         </p:txBody>
@@ -4852,7 +4852,7 @@
               </a:defRPr>
             </a:pPr>
             <a:r>
-              <a:t>•   Solving network splits &amp; split-brain scenarios</a:t>
+              <a:t>•   Symptom: Disk reports 100% full, but directories appear empty</a:t>
             </a:r>
           </a:p>
           <a:p>
@@ -4871,7 +4871,7 @@
               </a:defRPr>
             </a:pPr>
             <a:r>
-              <a:t>•   Handling cascading resource starvation failures</a:t>
+              <a:t>•   Root Cause: Deleted logs still held open by application handles</a:t>
             </a:r>
           </a:p>
         </p:txBody>
@@ -5017,7 +5017,7 @@
               </a:defRPr>
             </a:pPr>
             <a:r>
-              <a:t>•   Rolling back corrupted configurations with GitOps</a:t>
+              <a:t>•   Resolution: Use lsof +L1 to find PIDs and truncate fd in /proc</a:t>
             </a:r>
           </a:p>
           <a:p>
@@ -5033,7 +5033,7 @@
               </a:defRPr>
             </a:pPr>
             <a:r>
-              <a:t>Key Takeaway: Automate recovery; human steps should only confirm success.</a:t>
+              <a:t>Key Takeaway: Always verify open file handles before forcing application restarts.</a:t>
             </a:r>
           </a:p>
         </p:txBody>
@@ -5130,7 +5130,7 @@
               </a:defRPr>
             </a:pPr>
             <a:r>
-              <a:t>6-Month Expert Learning Roadmap</a:t>
+              <a:t>6-Month Linux Mastery Path</a:t>
             </a:r>
           </a:p>
           <a:p>
@@ -5146,7 +5146,7 @@
               </a:defRPr>
             </a:pPr>
             <a:r>
-              <a:t>Strategic Path to Linux Mastery</a:t>
+              <a:t>Strategic Milestones for Principal Engineers</a:t>
             </a:r>
           </a:p>
         </p:txBody>
@@ -5286,7 +5286,7 @@
               </a:defRPr>
             </a:pPr>
             <a:r>
-              <a:t>Weeks 1-2: Advanced Core Internals &amp; Local Mocking</a:t>
+              <a:t>Weeks 1-2: Master Kernel Internals &amp; Advanced Shell Diagnostics</a:t>
             </a:r>
           </a:p>
         </p:txBody>
@@ -5383,7 +5383,7 @@
               </a:defRPr>
             </a:pPr>
             <a:r>
-              <a:t>Weeks 3-4: Multi-cloud Deployment &amp; Terraform Automation</a:t>
+              <a:t>Weeks 3-4: Construct Sandboxed Daemons &amp; Tuning Profiles</a:t>
             </a:r>
           </a:p>
         </p:txBody>
@@ -5480,7 +5480,7 @@
               </a:defRPr>
             </a:pPr>
             <a:r>
-              <a:t>Weeks 5-6: Chaos Engineering &amp; Live-Traffic Drills</a:t>
+              <a:t>Weeks 5-6: Conduct Chaos Load Tests &amp; OS Hardening Audits</a:t>
             </a:r>
           </a:p>
         </p:txBody>
@@ -5516,7 +5516,7 @@
               </a:defRPr>
             </a:pPr>
             <a:r>
-              <a:t>Goal: Transition from conceptual understanding to live production ownership.</a:t>
+              <a:t>Goal: Transition from system administration to core system design.</a:t>
             </a:r>
           </a:p>
         </p:txBody>

</xml_diff>